<commit_message>
MODIS data input and output is working
The code runs successfully for the landcover submodule. For each chunk
MODIS data are read, converted, regridded, writting to the output file,
and plotted.
This is still demonstration code to get a working structure that can
be easily expanded.

(cherry picked from commit 1062844bcbe5e0f40d0953419eb5c8ffa085ac8c)
</commit_message>
<xml_diff>
--- a/landgen_flowchart.pptx
+++ b/landgen_flowchart.pptx
@@ -6,6 +6,9 @@
   </p:sldMasterIdLst>
   <p:sldIdLst>
     <p:sldId id="256" r:id="rId7"/>
+    <p:sldId id="257" r:id="rId8"/>
+    <p:sldId id="258" r:id="rId9"/>
+    <p:sldId id="259" r:id="rId10"/>
   </p:sldIdLst>
   <p:sldSz cx="18288000" cy="12801600" type="screen4x3"/>
   <p:notesSz cx="6858000" cy="9144000"/>
@@ -3112,7 +3115,7 @@
           <a:p>
             <a:pPr algn="ctr"/>
             <a:r>
-              <a:rPr sz="2200" b="1">
+              <a:rPr sz="2600" b="1">
                 <a:solidFill>
                   <a:srgbClr val="1F497D"/>
                 </a:solidFill>
@@ -3131,7 +3134,7 @@
         <p:spPr>
           <a:xfrm>
             <a:off x="182880" y="640080"/>
-            <a:ext cx="2011680" cy="274320"/>
+            <a:ext cx="2011680" cy="502920"/>
           </a:xfrm>
           <a:prstGeom prst="roundRect">
             <a:avLst/>
@@ -3165,7 +3168,7 @@
           <a:p>
             <a:pPr algn="ctr"/>
             <a:r>
-              <a:rPr sz="950" b="0">
+              <a:rPr sz="1800" b="0">
                 <a:solidFill>
                   <a:srgbClr val="FFFFFF"/>
                 </a:solidFill>
@@ -3184,7 +3187,7 @@
         <p:spPr>
           <a:xfrm>
             <a:off x="2377440" y="640080"/>
-            <a:ext cx="2011680" cy="274320"/>
+            <a:ext cx="2011680" cy="502920"/>
           </a:xfrm>
           <a:prstGeom prst="roundRect">
             <a:avLst/>
@@ -3218,7 +3221,7 @@
           <a:p>
             <a:pPr algn="ctr"/>
             <a:r>
-              <a:rPr sz="950" b="0">
+              <a:rPr sz="1800" b="0">
                 <a:solidFill>
                   <a:srgbClr val="FFFFFF"/>
                 </a:solidFill>
@@ -3237,7 +3240,7 @@
         <p:spPr>
           <a:xfrm>
             <a:off x="4572000" y="640080"/>
-            <a:ext cx="2011680" cy="274320"/>
+            <a:ext cx="2011680" cy="502920"/>
           </a:xfrm>
           <a:prstGeom prst="roundRect">
             <a:avLst/>
@@ -3271,7 +3274,7 @@
           <a:p>
             <a:pPr algn="ctr"/>
             <a:r>
-              <a:rPr sz="950" b="0">
+              <a:rPr sz="1800" b="0">
                 <a:solidFill>
                   <a:srgbClr val="FFFFFF"/>
                 </a:solidFill>
@@ -3290,7 +3293,7 @@
         <p:spPr>
           <a:xfrm>
             <a:off x="6766559" y="640080"/>
-            <a:ext cx="2011680" cy="274320"/>
+            <a:ext cx="2011680" cy="502920"/>
           </a:xfrm>
           <a:prstGeom prst="roundRect">
             <a:avLst/>
@@ -3324,7 +3327,7 @@
           <a:p>
             <a:pPr algn="ctr"/>
             <a:r>
-              <a:rPr sz="950" b="0">
+              <a:rPr sz="1800" b="0">
                 <a:solidFill>
                   <a:srgbClr val="FFFFFF"/>
                 </a:solidFill>
@@ -3343,7 +3346,7 @@
         <p:spPr>
           <a:xfrm>
             <a:off x="8961120" y="640080"/>
-            <a:ext cx="2011680" cy="274320"/>
+            <a:ext cx="2011680" cy="502920"/>
           </a:xfrm>
           <a:prstGeom prst="roundRect">
             <a:avLst/>
@@ -3377,7 +3380,7 @@
           <a:p>
             <a:pPr algn="ctr"/>
             <a:r>
-              <a:rPr sz="950" b="0">
+              <a:rPr sz="1800" b="0">
                 <a:solidFill>
                   <a:srgbClr val="FFFFFF"/>
                 </a:solidFill>
@@ -3396,7 +3399,7 @@
         <p:spPr>
           <a:xfrm>
             <a:off x="11155680" y="640080"/>
-            <a:ext cx="2011680" cy="274320"/>
+            <a:ext cx="2011680" cy="502920"/>
           </a:xfrm>
           <a:prstGeom prst="roundRect">
             <a:avLst/>
@@ -3430,7 +3433,7 @@
           <a:p>
             <a:pPr algn="ctr"/>
             <a:r>
-              <a:rPr sz="950" b="0">
+              <a:rPr sz="1800" b="0">
                 <a:solidFill>
                   <a:srgbClr val="FFFFFF"/>
                 </a:solidFill>
@@ -3449,7 +3452,7 @@
         <p:spPr>
           <a:xfrm>
             <a:off x="13350239" y="640080"/>
-            <a:ext cx="2011680" cy="274320"/>
+            <a:ext cx="2011680" cy="502920"/>
           </a:xfrm>
           <a:prstGeom prst="roundRect">
             <a:avLst/>
@@ -3483,7 +3486,7 @@
           <a:p>
             <a:pPr algn="ctr"/>
             <a:r>
-              <a:rPr sz="950" b="0">
+              <a:rPr sz="1800" b="0">
                 <a:solidFill>
                   <a:srgbClr val="FFFFFF"/>
                 </a:solidFill>
@@ -3502,7 +3505,7 @@
         <p:spPr>
           <a:xfrm>
             <a:off x="15544800" y="640080"/>
-            <a:ext cx="2011680" cy="274320"/>
+            <a:ext cx="2011680" cy="502920"/>
           </a:xfrm>
           <a:prstGeom prst="roundRect">
             <a:avLst/>
@@ -3536,7 +3539,7 @@
           <a:p>
             <a:pPr algn="ctr"/>
             <a:r>
-              <a:rPr sz="950" b="0">
+              <a:rPr sz="1800" b="0">
                 <a:solidFill>
                   <a:srgbClr val="FFFFFF"/>
                 </a:solidFill>
@@ -3554,8 +3557,8 @@
         </p:nvSpPr>
         <p:spPr>
           <a:xfrm>
-            <a:off x="8321040" y="1097280"/>
-            <a:ext cx="2560320" cy="411480"/>
+            <a:off x="7223760" y="1371600"/>
+            <a:ext cx="3931920" cy="868680"/>
           </a:xfrm>
           <a:prstGeom prst="roundRect">
             <a:avLst/>
@@ -3589,7 +3592,7 @@
           <a:p>
             <a:pPr algn="ctr"/>
             <a:r>
-              <a:rPr sz="1000" b="1">
+              <a:rPr sz="1800" b="1">
                 <a:solidFill>
                   <a:srgbClr val="FFFFFF"/>
                 </a:solidFill>
@@ -3608,8 +3611,8 @@
         </p:nvSpPr>
         <p:spPr>
           <a:xfrm>
-            <a:off x="11887200" y="1097280"/>
-            <a:ext cx="2011680" cy="411480"/>
+            <a:off x="12161520" y="1371600"/>
+            <a:ext cx="2834640" cy="868680"/>
           </a:xfrm>
           <a:prstGeom prst="roundRect">
             <a:avLst/>
@@ -3643,7 +3646,7 @@
           <a:p>
             <a:pPr algn="ctr"/>
             <a:r>
-              <a:rPr sz="1000" b="0">
+              <a:rPr sz="1800" b="0">
                 <a:solidFill>
                   <a:srgbClr val="FFFFFF"/>
                 </a:solidFill>
@@ -3662,7 +3665,7 @@
         </p:nvCxnSpPr>
         <p:spPr>
           <a:xfrm flipH="1">
-            <a:off x="10881360" y="1303020"/>
+            <a:off x="11155680" y="1805940"/>
             <a:ext cx="1005840" cy="1"/>
           </a:xfrm>
           <a:prstGeom prst="line">
@@ -3678,47 +3681,14 @@
       </p:cxnSp>
       <p:sp>
         <p:nvSpPr>
-          <p:cNvPr id="14" name="TextBox 13"/>
-          <p:cNvSpPr txBox="1"/>
-          <p:nvPr/>
-        </p:nvSpPr>
-        <p:spPr>
-          <a:xfrm>
-            <a:off x="11384280" y="1193292"/>
-            <a:ext cx="822960" cy="182880"/>
-          </a:xfrm>
-          <a:prstGeom prst="rect">
-            <a:avLst/>
-          </a:prstGeom>
-          <a:noFill/>
-        </p:spPr>
-        <p:txBody>
-          <a:bodyPr wrap="none">
-            <a:spAutoFit/>
-          </a:bodyPr>
-          <a:lstStyle/>
-          <a:p>
-            <a:r>
-              <a:rPr sz="900">
-                <a:solidFill>
-                  <a:srgbClr val="404040"/>
-                </a:solidFill>
-              </a:rPr>
-              <a:t>reads</a:t>
-            </a:r>
-          </a:p>
-        </p:txBody>
-      </p:sp>
-      <p:sp>
-        <p:nvSpPr>
-          <p:cNvPr id="15" name="Rounded Rectangle 14"/>
+          <p:cNvPr id="14" name="Rounded Rectangle 13"/>
           <p:cNvSpPr/>
           <p:nvPr/>
         </p:nvSpPr>
         <p:spPr>
           <a:xfrm>
-            <a:off x="7863840" y="2011680"/>
-            <a:ext cx="3474720" cy="411480"/>
+            <a:off x="6675120" y="2834640"/>
+            <a:ext cx="4754880" cy="1463040"/>
           </a:xfrm>
           <a:prstGeom prst="roundRect">
             <a:avLst/>
@@ -3752,7 +3722,7 @@
           <a:p>
             <a:pPr algn="ctr"/>
             <a:r>
-              <a:rPr sz="1000" b="1">
+              <a:rPr sz="1800" b="1">
                 <a:solidFill>
                   <a:srgbClr val="FFFFFF"/>
                 </a:solidFill>
@@ -3766,14 +3736,14 @@
       </p:sp>
       <p:cxnSp>
         <p:nvCxnSpPr>
-          <p:cNvPr id="16" name="Arrow 16"/>
+          <p:cNvPr id="15" name="Arrow 15"/>
           <p:cNvCxnSpPr/>
           <p:nvPr/>
         </p:nvCxnSpPr>
         <p:spPr>
-          <a:xfrm>
-            <a:off x="9601200" y="1508760"/>
-            <a:ext cx="1" cy="502920"/>
+          <a:xfrm flipH="1">
+            <a:off x="9052560" y="2240280"/>
+            <a:ext cx="137160" cy="594360"/>
           </a:xfrm>
           <a:prstGeom prst="line">
             <a:avLst/>
@@ -3788,14 +3758,14 @@
       </p:cxnSp>
       <p:sp>
         <p:nvSpPr>
-          <p:cNvPr id="17" name="Rounded Rectangle 16"/>
+          <p:cNvPr id="16" name="Rounded Rectangle 15"/>
           <p:cNvSpPr/>
           <p:nvPr/>
         </p:nvSpPr>
         <p:spPr>
           <a:xfrm>
-            <a:off x="12618720" y="2011680"/>
-            <a:ext cx="5303520" cy="1234440"/>
+            <a:off x="11887200" y="2834640"/>
+            <a:ext cx="6035040" cy="1965960"/>
           </a:xfrm>
           <a:prstGeom prst="roundRect">
             <a:avLst/>
@@ -3829,7 +3799,7 @@
           <a:p>
             <a:pPr algn="ctr"/>
             <a:r>
-              <a:rPr sz="800" b="0">
+              <a:rPr sz="1800" b="0">
                 <a:solidFill>
                   <a:srgbClr val="FFFFFF"/>
                 </a:solidFill>
@@ -3844,14 +3814,14 @@
       </p:sp>
       <p:cxnSp>
         <p:nvCxnSpPr>
-          <p:cNvPr id="18" name="Arrow 18"/>
+          <p:cNvPr id="17" name="Arrow 17"/>
           <p:cNvCxnSpPr/>
           <p:nvPr/>
         </p:nvCxnSpPr>
         <p:spPr>
           <a:xfrm>
-            <a:off x="11338560" y="2217420"/>
-            <a:ext cx="1280160" cy="411480"/>
+            <a:off x="11430000" y="3566160"/>
+            <a:ext cx="457200" cy="251460"/>
           </a:xfrm>
           <a:prstGeom prst="line">
             <a:avLst/>
@@ -3866,47 +3836,14 @@
       </p:cxnSp>
       <p:sp>
         <p:nvSpPr>
-          <p:cNvPr id="19" name="TextBox 18"/>
-          <p:cNvSpPr txBox="1"/>
-          <p:nvPr/>
-        </p:nvSpPr>
-        <p:spPr>
-          <a:xfrm>
-            <a:off x="11978640" y="2313432"/>
-            <a:ext cx="822960" cy="182880"/>
-          </a:xfrm>
-          <a:prstGeom prst="rect">
-            <a:avLst/>
-          </a:prstGeom>
-          <a:noFill/>
-        </p:spPr>
-        <p:txBody>
-          <a:bodyPr wrap="none">
-            <a:spAutoFit/>
-          </a:bodyPr>
-          <a:lstStyle/>
-          <a:p>
-            <a:r>
-              <a:rPr sz="900">
-                <a:solidFill>
-                  <a:srgbClr val="404040"/>
-                </a:solidFill>
-              </a:rPr>
-              <a:t>uses</a:t>
-            </a:r>
-          </a:p>
-        </p:txBody>
-      </p:sp>
-      <p:sp>
-        <p:nvSpPr>
-          <p:cNvPr id="20" name="Rounded Rectangle 19"/>
+          <p:cNvPr id="18" name="Rounded Rectangle 17"/>
           <p:cNvSpPr/>
           <p:nvPr/>
         </p:nvSpPr>
         <p:spPr>
           <a:xfrm>
-            <a:off x="731520" y="3794760"/>
-            <a:ext cx="3108960" cy="777240"/>
+            <a:off x="274320" y="5669280"/>
+            <a:ext cx="3291840" cy="1143000"/>
           </a:xfrm>
           <a:prstGeom prst="roundRect">
             <a:avLst/>
@@ -3940,7 +3877,7 @@
           <a:p>
             <a:pPr algn="ctr"/>
             <a:r>
-              <a:rPr sz="1000" b="0">
+              <a:rPr sz="1800" b="0">
                 <a:solidFill>
                   <a:srgbClr val="FFFFFF"/>
                 </a:solidFill>
@@ -3955,14 +3892,14 @@
       </p:sp>
       <p:cxnSp>
         <p:nvCxnSpPr>
-          <p:cNvPr id="21" name="Arrow 21"/>
+          <p:cNvPr id="19" name="Arrow 19"/>
           <p:cNvCxnSpPr/>
           <p:nvPr/>
         </p:nvCxnSpPr>
         <p:spPr>
           <a:xfrm flipH="1">
-            <a:off x="2286000" y="2423160"/>
-            <a:ext cx="7315200" cy="1371600"/>
+            <a:off x="1920240" y="4297680"/>
+            <a:ext cx="7132320" cy="1371600"/>
           </a:xfrm>
           <a:prstGeom prst="line">
             <a:avLst/>
@@ -3977,14 +3914,14 @@
       </p:cxnSp>
       <p:sp>
         <p:nvSpPr>
-          <p:cNvPr id="22" name="Rounded Rectangle 21"/>
+          <p:cNvPr id="20" name="Rounded Rectangle 19"/>
           <p:cNvSpPr/>
           <p:nvPr/>
         </p:nvSpPr>
         <p:spPr>
           <a:xfrm>
-            <a:off x="4160520" y="3794760"/>
-            <a:ext cx="3108960" cy="777240"/>
+            <a:off x="3886200" y="5669280"/>
+            <a:ext cx="3291840" cy="1143000"/>
           </a:xfrm>
           <a:prstGeom prst="roundRect">
             <a:avLst/>
@@ -4018,7 +3955,7 @@
           <a:p>
             <a:pPr algn="ctr"/>
             <a:r>
-              <a:rPr sz="1000" b="0">
+              <a:rPr sz="1800" b="0">
                 <a:solidFill>
                   <a:srgbClr val="FFFFFF"/>
                 </a:solidFill>
@@ -4033,14 +3970,14 @@
       </p:sp>
       <p:cxnSp>
         <p:nvCxnSpPr>
-          <p:cNvPr id="23" name="Arrow 23"/>
+          <p:cNvPr id="21" name="Arrow 21"/>
           <p:cNvCxnSpPr/>
           <p:nvPr/>
         </p:nvCxnSpPr>
         <p:spPr>
           <a:xfrm flipH="1">
-            <a:off x="5715000" y="2423160"/>
-            <a:ext cx="3886200" cy="1371600"/>
+            <a:off x="5532120" y="4297680"/>
+            <a:ext cx="3520440" cy="1371600"/>
           </a:xfrm>
           <a:prstGeom prst="line">
             <a:avLst/>
@@ -4055,14 +3992,14 @@
       </p:cxnSp>
       <p:sp>
         <p:nvSpPr>
-          <p:cNvPr id="24" name="Rounded Rectangle 23"/>
+          <p:cNvPr id="22" name="Rounded Rectangle 21"/>
           <p:cNvSpPr/>
           <p:nvPr/>
         </p:nvSpPr>
         <p:spPr>
           <a:xfrm>
-            <a:off x="7589520" y="3794760"/>
-            <a:ext cx="3108960" cy="777240"/>
+            <a:off x="7498080" y="5669280"/>
+            <a:ext cx="3291840" cy="1143000"/>
           </a:xfrm>
           <a:prstGeom prst="roundRect">
             <a:avLst/>
@@ -4096,29 +4033,27 @@
           <a:p>
             <a:pPr algn="ctr"/>
             <a:r>
-              <a:rPr sz="1000" b="0">
+              <a:rPr sz="1800" b="0">
                 <a:solidFill>
                   <a:srgbClr val="FFFFFF"/>
                 </a:solidFill>
               </a:rPr>
-              <a:t>atmosphere.py
-run()
-[ndep, pdep,
-lightning]</a:t>
+              <a:t>soil.py
+run()</a:t>
             </a:r>
           </a:p>
         </p:txBody>
       </p:sp>
       <p:cxnSp>
         <p:nvCxnSpPr>
-          <p:cNvPr id="25" name="Arrow 25"/>
+          <p:cNvPr id="23" name="Arrow 23"/>
           <p:cNvCxnSpPr/>
           <p:nvPr/>
         </p:nvCxnSpPr>
         <p:spPr>
-          <a:xfrm flipH="1">
-            <a:off x="9144000" y="2423160"/>
-            <a:ext cx="457200" cy="1371600"/>
+          <a:xfrm>
+            <a:off x="9052560" y="4297680"/>
+            <a:ext cx="91440" cy="1371600"/>
           </a:xfrm>
           <a:prstGeom prst="line">
             <a:avLst/>
@@ -4133,14 +4068,14 @@
       </p:cxnSp>
       <p:sp>
         <p:nvSpPr>
-          <p:cNvPr id="26" name="Rounded Rectangle 25"/>
+          <p:cNvPr id="24" name="Rounded Rectangle 23"/>
           <p:cNvSpPr/>
           <p:nvPr/>
         </p:nvSpPr>
         <p:spPr>
           <a:xfrm>
-            <a:off x="11018520" y="3794760"/>
-            <a:ext cx="3108960" cy="777240"/>
+            <a:off x="11109960" y="5669280"/>
+            <a:ext cx="3291840" cy="1143000"/>
           </a:xfrm>
           <a:prstGeom prst="roundRect">
             <a:avLst/>
@@ -4174,29 +4109,27 @@
           <a:p>
             <a:pPr algn="ctr"/>
             <a:r>
-              <a:rPr sz="1000" b="0">
+              <a:rPr sz="1800" b="0">
                 <a:solidFill>
                   <a:srgbClr val="FFFFFF"/>
                 </a:solidFill>
               </a:rPr>
-              <a:t>soil.py
-run()
-[soil texture,
-organic matter]</a:t>
+              <a:t>human.py
+run()</a:t>
             </a:r>
           </a:p>
         </p:txBody>
       </p:sp>
       <p:cxnSp>
         <p:nvCxnSpPr>
-          <p:cNvPr id="27" name="Arrow 27"/>
+          <p:cNvPr id="25" name="Arrow 25"/>
           <p:cNvCxnSpPr/>
           <p:nvPr/>
         </p:nvCxnSpPr>
         <p:spPr>
           <a:xfrm>
-            <a:off x="9601200" y="2423160"/>
-            <a:ext cx="2971800" cy="1371600"/>
+            <a:off x="9052560" y="4297680"/>
+            <a:ext cx="3703320" cy="1371600"/>
           </a:xfrm>
           <a:prstGeom prst="line">
             <a:avLst/>
@@ -4211,14 +4144,14 @@
       </p:cxnSp>
       <p:sp>
         <p:nvSpPr>
-          <p:cNvPr id="28" name="Rounded Rectangle 27"/>
+          <p:cNvPr id="26" name="Rounded Rectangle 25"/>
           <p:cNvSpPr/>
           <p:nvPr/>
         </p:nvSpPr>
         <p:spPr>
           <a:xfrm>
-            <a:off x="14447520" y="3794760"/>
-            <a:ext cx="3108960" cy="777240"/>
+            <a:off x="14721840" y="5669280"/>
+            <a:ext cx="3291840" cy="1143000"/>
           </a:xfrm>
           <a:prstGeom prst="roundRect">
             <a:avLst/>
@@ -4252,29 +4185,27 @@
           <a:p>
             <a:pPr algn="ctr"/>
             <a:r>
-              <a:rPr sz="1000" b="0">
+              <a:rPr sz="1800" b="0">
                 <a:solidFill>
                   <a:srgbClr val="FFFFFF"/>
                 </a:solidFill>
               </a:rPr>
-              <a:t>human.py
-run()
-[population,
-GDP]</a:t>
+              <a:t>atmosphere.py
+run()</a:t>
             </a:r>
           </a:p>
         </p:txBody>
       </p:sp>
       <p:cxnSp>
         <p:nvCxnSpPr>
-          <p:cNvPr id="29" name="Arrow 29"/>
+          <p:cNvPr id="27" name="Arrow 27"/>
           <p:cNvCxnSpPr/>
           <p:nvPr/>
         </p:nvCxnSpPr>
         <p:spPr>
           <a:xfrm>
-            <a:off x="9601200" y="2423160"/>
-            <a:ext cx="6400800" cy="1371600"/>
+            <a:off x="9052560" y="4297680"/>
+            <a:ext cx="7315200" cy="1371600"/>
           </a:xfrm>
           <a:prstGeom prst="line">
             <a:avLst/>
@@ -4289,14 +4220,14 @@
       </p:cxnSp>
       <p:sp>
         <p:nvSpPr>
-          <p:cNvPr id="30" name="Rounded Rectangle 29"/>
+          <p:cNvPr id="28" name="Rounded Rectangle 27"/>
           <p:cNvSpPr/>
           <p:nvPr/>
         </p:nvSpPr>
         <p:spPr>
           <a:xfrm>
-            <a:off x="4160520" y="5074920"/>
-            <a:ext cx="3108960" cy="411480"/>
+            <a:off x="3886200" y="7543800"/>
+            <a:ext cx="3108960" cy="822960"/>
           </a:xfrm>
           <a:prstGeom prst="roundRect">
             <a:avLst/>
@@ -4330,7 +4261,7 @@
           <a:p>
             <a:pPr algn="ctr"/>
             <a:r>
-              <a:rPr sz="1000" b="0">
+              <a:rPr sz="1800" b="0">
                 <a:solidFill>
                   <a:srgbClr val="FFFFFF"/>
                 </a:solidFill>
@@ -4343,14 +4274,14 @@
       </p:sp>
       <p:cxnSp>
         <p:nvCxnSpPr>
-          <p:cNvPr id="31" name="Arrow 31"/>
+          <p:cNvPr id="29" name="Arrow 29"/>
           <p:cNvCxnSpPr/>
           <p:nvPr/>
         </p:nvCxnSpPr>
         <p:spPr>
           <a:xfrm>
-            <a:off x="5715000" y="4572000"/>
-            <a:ext cx="1" cy="502920"/>
+            <a:off x="5440680" y="6812280"/>
+            <a:ext cx="1" cy="731520"/>
           </a:xfrm>
           <a:prstGeom prst="line">
             <a:avLst/>
@@ -4365,14 +4296,14 @@
       </p:cxnSp>
       <p:sp>
         <p:nvSpPr>
-          <p:cNvPr id="32" name="Rounded Rectangle 31"/>
+          <p:cNvPr id="30" name="Rounded Rectangle 29"/>
           <p:cNvSpPr/>
           <p:nvPr/>
         </p:nvSpPr>
         <p:spPr>
           <a:xfrm>
-            <a:off x="256032" y="5897880"/>
-            <a:ext cx="1828800" cy="685800"/>
+            <a:off x="2253999" y="9098280"/>
+            <a:ext cx="1874519" cy="914400"/>
           </a:xfrm>
           <a:prstGeom prst="roundRect">
             <a:avLst/>
@@ -4406,28 +4337,27 @@
           <a:p>
             <a:pPr algn="ctr"/>
             <a:r>
-              <a:rPr sz="950" b="0">
+              <a:rPr sz="1800" b="0">
                 <a:solidFill>
                   <a:srgbClr val="FFFFFF"/>
                 </a:solidFill>
               </a:rPr>
               <a:t>landcover.py
-run() → landcover_
-process() [parallel]</a:t>
+run() [parallel]</a:t>
             </a:r>
           </a:p>
         </p:txBody>
       </p:sp>
       <p:cxnSp>
         <p:nvCxnSpPr>
-          <p:cNvPr id="33" name="Arrow 33"/>
+          <p:cNvPr id="31" name="Arrow 31"/>
           <p:cNvCxnSpPr/>
           <p:nvPr/>
         </p:nvCxnSpPr>
         <p:spPr>
           <a:xfrm flipH="1">
-            <a:off x="1170432" y="5486400"/>
-            <a:ext cx="4544568" cy="411480"/>
+            <a:off x="3191259" y="8366760"/>
+            <a:ext cx="2249421" cy="731520"/>
           </a:xfrm>
           <a:prstGeom prst="line">
             <a:avLst/>
@@ -4442,14 +4372,14 @@
       </p:cxnSp>
       <p:sp>
         <p:nvSpPr>
-          <p:cNvPr id="34" name="Rounded Rectangle 33"/>
+          <p:cNvPr id="32" name="Rounded Rectangle 31"/>
           <p:cNvSpPr/>
           <p:nvPr/>
         </p:nvSpPr>
         <p:spPr>
           <a:xfrm>
-            <a:off x="2249424" y="5897880"/>
-            <a:ext cx="1828800" cy="685800"/>
+            <a:off x="4238246" y="9098280"/>
+            <a:ext cx="1874519" cy="914400"/>
           </a:xfrm>
           <a:prstGeom prst="roundRect">
             <a:avLst/>
@@ -4483,7 +4413,7 @@
           <a:p>
             <a:pPr algn="ctr"/>
             <a:r>
-              <a:rPr sz="950" b="0">
+              <a:rPr sz="1800" b="0">
                 <a:solidFill>
                   <a:srgbClr val="FFFFFF"/>
                 </a:solidFill>
@@ -4497,14 +4427,14 @@
       </p:sp>
       <p:cxnSp>
         <p:nvCxnSpPr>
-          <p:cNvPr id="35" name="Arrow 35"/>
+          <p:cNvPr id="33" name="Arrow 33"/>
           <p:cNvCxnSpPr/>
           <p:nvPr/>
         </p:nvCxnSpPr>
         <p:spPr>
           <a:xfrm flipH="1">
-            <a:off x="3163824" y="5486400"/>
-            <a:ext cx="2551176" cy="411480"/>
+            <a:off x="5175506" y="8366760"/>
+            <a:ext cx="265174" cy="731520"/>
           </a:xfrm>
           <a:prstGeom prst="line">
             <a:avLst/>
@@ -4519,14 +4449,14 @@
       </p:cxnSp>
       <p:sp>
         <p:nvSpPr>
-          <p:cNvPr id="36" name="Rounded Rectangle 35"/>
+          <p:cNvPr id="34" name="Rounded Rectangle 33"/>
           <p:cNvSpPr/>
           <p:nvPr/>
         </p:nvSpPr>
         <p:spPr>
           <a:xfrm>
-            <a:off x="4242816" y="5897880"/>
-            <a:ext cx="1828800" cy="685800"/>
+            <a:off x="6222493" y="9098280"/>
+            <a:ext cx="1874519" cy="914400"/>
           </a:xfrm>
           <a:prstGeom prst="roundRect">
             <a:avLst/>
@@ -4560,7 +4490,7 @@
           <a:p>
             <a:pPr algn="ctr"/>
             <a:r>
-              <a:rPr sz="950" b="0">
+              <a:rPr sz="1800" b="0">
                 <a:solidFill>
                   <a:srgbClr val="FFFFFF"/>
                 </a:solidFill>
@@ -4574,14 +4504,14 @@
       </p:sp>
       <p:cxnSp>
         <p:nvCxnSpPr>
-          <p:cNvPr id="37" name="Arrow 37"/>
+          <p:cNvPr id="35" name="Arrow 35"/>
           <p:cNvCxnSpPr/>
           <p:nvPr/>
         </p:nvCxnSpPr>
         <p:spPr>
-          <a:xfrm flipH="1">
-            <a:off x="5157216" y="5486400"/>
-            <a:ext cx="557784" cy="411480"/>
+          <a:xfrm>
+            <a:off x="5440680" y="8366760"/>
+            <a:ext cx="1719073" cy="731520"/>
           </a:xfrm>
           <a:prstGeom prst="line">
             <a:avLst/>
@@ -4596,14 +4526,14 @@
       </p:cxnSp>
       <p:sp>
         <p:nvSpPr>
-          <p:cNvPr id="38" name="Rounded Rectangle 37"/>
+          <p:cNvPr id="36" name="Rounded Rectangle 35"/>
           <p:cNvSpPr/>
           <p:nvPr/>
         </p:nvSpPr>
         <p:spPr>
           <a:xfrm>
-            <a:off x="6236208" y="5897880"/>
-            <a:ext cx="1828800" cy="685800"/>
+            <a:off x="8206740" y="9098280"/>
+            <a:ext cx="1874519" cy="914400"/>
           </a:xfrm>
           <a:prstGeom prst="roundRect">
             <a:avLst/>
@@ -4637,7 +4567,7 @@
           <a:p>
             <a:pPr algn="ctr"/>
             <a:r>
-              <a:rPr sz="950" b="0">
+              <a:rPr sz="1800" b="0">
                 <a:solidFill>
                   <a:srgbClr val="FFFFFF"/>
                 </a:solidFill>
@@ -4651,14 +4581,14 @@
       </p:sp>
       <p:cxnSp>
         <p:nvCxnSpPr>
-          <p:cNvPr id="39" name="Arrow 39"/>
+          <p:cNvPr id="37" name="Arrow 37"/>
           <p:cNvCxnSpPr/>
           <p:nvPr/>
         </p:nvCxnSpPr>
         <p:spPr>
           <a:xfrm>
-            <a:off x="5715000" y="5486400"/>
-            <a:ext cx="1435608" cy="411480"/>
+            <a:off x="5440680" y="8366760"/>
+            <a:ext cx="3703320" cy="731520"/>
           </a:xfrm>
           <a:prstGeom prst="line">
             <a:avLst/>
@@ -4673,14 +4603,14 @@
       </p:cxnSp>
       <p:sp>
         <p:nvSpPr>
-          <p:cNvPr id="40" name="Rounded Rectangle 39"/>
+          <p:cNvPr id="38" name="Rounded Rectangle 37"/>
           <p:cNvSpPr/>
           <p:nvPr/>
         </p:nvSpPr>
         <p:spPr>
           <a:xfrm>
-            <a:off x="8229600" y="5897880"/>
-            <a:ext cx="1828800" cy="685800"/>
+            <a:off x="10190987" y="9098280"/>
+            <a:ext cx="1874519" cy="914400"/>
           </a:xfrm>
           <a:prstGeom prst="roundRect">
             <a:avLst/>
@@ -4714,7 +4644,7 @@
           <a:p>
             <a:pPr algn="ctr"/>
             <a:r>
-              <a:rPr sz="950" b="0">
+              <a:rPr sz="1800" b="0">
                 <a:solidFill>
                   <a:srgbClr val="FFFFFF"/>
                 </a:solidFill>
@@ -4728,14 +4658,14 @@
       </p:sp>
       <p:cxnSp>
         <p:nvCxnSpPr>
-          <p:cNvPr id="41" name="Arrow 41"/>
+          <p:cNvPr id="39" name="Arrow 39"/>
           <p:cNvCxnSpPr/>
           <p:nvPr/>
         </p:nvCxnSpPr>
         <p:spPr>
           <a:xfrm>
-            <a:off x="5715000" y="5486400"/>
-            <a:ext cx="3429000" cy="411480"/>
+            <a:off x="5440680" y="8366760"/>
+            <a:ext cx="5687567" cy="731520"/>
           </a:xfrm>
           <a:prstGeom prst="line">
             <a:avLst/>
@@ -4750,14 +4680,14 @@
       </p:cxnSp>
       <p:sp>
         <p:nvSpPr>
-          <p:cNvPr id="42" name="Rounded Rectangle 41"/>
+          <p:cNvPr id="40" name="Rounded Rectangle 39"/>
           <p:cNvSpPr/>
           <p:nvPr/>
         </p:nvSpPr>
         <p:spPr>
           <a:xfrm>
-            <a:off x="10222992" y="5897880"/>
-            <a:ext cx="1828800" cy="685800"/>
+            <a:off x="12175234" y="9098280"/>
+            <a:ext cx="1874519" cy="914400"/>
           </a:xfrm>
           <a:prstGeom prst="roundRect">
             <a:avLst/>
@@ -4791,28 +4721,27 @@
           <a:p>
             <a:pPr algn="ctr"/>
             <a:r>
-              <a:rPr sz="950" b="0">
+              <a:rPr sz="1800" b="0">
                 <a:solidFill>
                   <a:srgbClr val="FFFFFF"/>
                 </a:solidFill>
               </a:rPr>
               <a:t>harvest.py
-run() → harvest_
-process() [parallel]</a:t>
+run() [parallel]</a:t>
             </a:r>
           </a:p>
         </p:txBody>
       </p:sp>
       <p:cxnSp>
         <p:nvCxnSpPr>
-          <p:cNvPr id="43" name="Arrow 43"/>
+          <p:cNvPr id="41" name="Arrow 41"/>
           <p:cNvCxnSpPr/>
           <p:nvPr/>
         </p:nvCxnSpPr>
         <p:spPr>
           <a:xfrm>
-            <a:off x="5715000" y="5486400"/>
-            <a:ext cx="5422392" cy="411480"/>
+            <a:off x="5440680" y="8366760"/>
+            <a:ext cx="7671814" cy="731520"/>
           </a:xfrm>
           <a:prstGeom prst="line">
             <a:avLst/>
@@ -4827,14 +4756,14 @@
       </p:cxnSp>
       <p:sp>
         <p:nvSpPr>
-          <p:cNvPr id="44" name="Rounded Rectangle 43"/>
+          <p:cNvPr id="42" name="Rounded Rectangle 41"/>
           <p:cNvSpPr/>
           <p:nvPr/>
         </p:nvSpPr>
         <p:spPr>
           <a:xfrm>
-            <a:off x="12216384" y="5897880"/>
-            <a:ext cx="1828800" cy="685800"/>
+            <a:off x="14159481" y="9098280"/>
+            <a:ext cx="1874519" cy="914400"/>
           </a:xfrm>
           <a:prstGeom prst="roundRect">
             <a:avLst/>
@@ -4868,84 +4797,7 @@
           <a:p>
             <a:pPr algn="ctr"/>
             <a:r>
-              <a:rPr sz="950" b="0">
-                <a:solidFill>
-                  <a:srgbClr val="FFFFFF"/>
-                </a:solidFill>
-              </a:rPr>
-              <a:t>normalize_cell
-fill_land +
-reconcile_ocean</a:t>
-            </a:r>
-          </a:p>
-        </p:txBody>
-      </p:sp>
-      <p:cxnSp>
-        <p:nvCxnSpPr>
-          <p:cNvPr id="45" name="Arrow 45"/>
-          <p:cNvCxnSpPr/>
-          <p:nvPr/>
-        </p:nvCxnSpPr>
-        <p:spPr>
-          <a:xfrm>
-            <a:off x="5715000" y="5486400"/>
-            <a:ext cx="7415784" cy="411480"/>
-          </a:xfrm>
-          <a:prstGeom prst="line">
-            <a:avLst/>
-          </a:prstGeom>
-          <a:ln w="19050">
-            <a:solidFill>
-              <a:srgbClr val="404040"/>
-            </a:solidFill>
-            <a:tailEnd type="arrow" w="med" len="med"/>
-          </a:ln>
-        </p:spPr>
-      </p:cxnSp>
-      <p:sp>
-        <p:nvSpPr>
-          <p:cNvPr id="46" name="Rounded Rectangle 45"/>
-          <p:cNvSpPr/>
-          <p:nvPr/>
-        </p:nvSpPr>
-        <p:spPr>
-          <a:xfrm>
-            <a:off x="14209776" y="5897880"/>
-            <a:ext cx="1828800" cy="685800"/>
-          </a:xfrm>
-          <a:prstGeom prst="roundRect">
-            <a:avLst/>
-          </a:prstGeom>
-          <a:solidFill>
-            <a:srgbClr val="A5A5A5"/>
-          </a:solidFill>
-          <a:ln w="9525">
-            <a:solidFill>
-              <a:srgbClr val="FFFFFF"/>
-            </a:solidFill>
-          </a:ln>
-        </p:spPr>
-        <p:style>
-          <a:lnRef idx="1">
-            <a:schemeClr val="accent1"/>
-          </a:lnRef>
-          <a:fillRef idx="3">
-            <a:schemeClr val="accent1"/>
-          </a:fillRef>
-          <a:effectRef idx="2">
-            <a:schemeClr val="accent1"/>
-          </a:effectRef>
-          <a:fontRef idx="minor">
-            <a:schemeClr val="lt1"/>
-          </a:fontRef>
-        </p:style>
-        <p:txBody>
-          <a:bodyPr rtlCol="0" anchor="ctr" wrap="square"/>
-          <a:lstStyle/>
-          <a:p>
-            <a:pPr algn="ctr"/>
-            <a:r>
-              <a:rPr sz="950" b="0">
+              <a:rPr sz="1800" b="0">
                 <a:solidFill>
                   <a:srgbClr val="FFFFFF"/>
                 </a:solidFill>
@@ -4959,14 +4811,14 @@
       </p:sp>
       <p:cxnSp>
         <p:nvCxnSpPr>
-          <p:cNvPr id="47" name="Arrow 47"/>
+          <p:cNvPr id="43" name="Arrow 43"/>
           <p:cNvCxnSpPr/>
           <p:nvPr/>
         </p:nvCxnSpPr>
         <p:spPr>
           <a:xfrm>
-            <a:off x="5715000" y="5486400"/>
-            <a:ext cx="9409176" cy="411480"/>
+            <a:off x="5440680" y="8366760"/>
+            <a:ext cx="9656061" cy="731520"/>
           </a:xfrm>
           <a:prstGeom prst="line">
             <a:avLst/>
@@ -4981,91 +4833,14 @@
       </p:cxnSp>
       <p:sp>
         <p:nvSpPr>
-          <p:cNvPr id="48" name="Rounded Rectangle 47"/>
+          <p:cNvPr id="44" name="Rounded Rectangle 43"/>
           <p:cNvSpPr/>
           <p:nvPr/>
         </p:nvSpPr>
         <p:spPr>
           <a:xfrm>
-            <a:off x="16203168" y="5897880"/>
-            <a:ext cx="1828800" cy="685800"/>
-          </a:xfrm>
-          <a:prstGeom prst="roundRect">
-            <a:avLst/>
-          </a:prstGeom>
-          <a:solidFill>
-            <a:srgbClr val="A5A5A5"/>
-          </a:solidFill>
-          <a:ln w="9525">
-            <a:solidFill>
-              <a:srgbClr val="FFFFFF"/>
-            </a:solidFill>
-          </a:ln>
-        </p:spPr>
-        <p:style>
-          <a:lnRef idx="1">
-            <a:schemeClr val="accent1"/>
-          </a:lnRef>
-          <a:fillRef idx="3">
-            <a:schemeClr val="accent1"/>
-          </a:fillRef>
-          <a:effectRef idx="2">
-            <a:schemeClr val="accent1"/>
-          </a:effectRef>
-          <a:fontRef idx="minor">
-            <a:schemeClr val="lt1"/>
-          </a:fontRef>
-        </p:style>
-        <p:txBody>
-          <a:bodyPr rtlCol="0" anchor="ctr" wrap="square"/>
-          <a:lstStyle/>
-          <a:p>
-            <a:pPr algn="ctr"/>
-            <a:r>
-              <a:rPr sz="950" b="0">
-                <a:solidFill>
-                  <a:srgbClr val="FFFFFF"/>
-                </a:solidFill>
-              </a:rPr>
-              <a:t>consistency.py
-run()
-[not yet impl.]</a:t>
-            </a:r>
-          </a:p>
-        </p:txBody>
-      </p:sp>
-      <p:cxnSp>
-        <p:nvCxnSpPr>
-          <p:cNvPr id="49" name="Arrow 49"/>
-          <p:cNvCxnSpPr/>
-          <p:nvPr/>
-        </p:nvCxnSpPr>
-        <p:spPr>
-          <a:xfrm>
-            <a:off x="5715000" y="5486400"/>
-            <a:ext cx="11402568" cy="411480"/>
-          </a:xfrm>
-          <a:prstGeom prst="line">
-            <a:avLst/>
-          </a:prstGeom>
-          <a:ln w="19050">
-            <a:solidFill>
-              <a:srgbClr val="404040"/>
-            </a:solidFill>
-            <a:tailEnd type="arrow" w="med" len="med"/>
-          </a:ln>
-        </p:spPr>
-      </p:cxnSp>
-      <p:sp>
-        <p:nvSpPr>
-          <p:cNvPr id="50" name="Rounded Rectangle 49"/>
-          <p:cNvSpPr/>
-          <p:nvPr/>
-        </p:nvSpPr>
-        <p:spPr>
-          <a:xfrm>
-            <a:off x="256032" y="6995160"/>
-            <a:ext cx="1828800" cy="868680"/>
+            <a:off x="3589020" y="10515600"/>
+            <a:ext cx="5394960" cy="2487168"/>
           </a:xfrm>
           <a:prstGeom prst="roundRect">
             <a:avLst/>
@@ -5099,30 +4874,32 @@
           <a:p>
             <a:pPr algn="ctr"/>
             <a:r>
-              <a:rPr sz="950" b="0">
+              <a:rPr sz="1800" b="0">
                 <a:solidFill>
                   <a:srgbClr val="FFFFFF"/>
                 </a:solidFill>
               </a:rPr>
               <a:t>landcover_process()
-· read MODIS / transitions
-· regrid (uraster)
-· split PFTs
-· write → LtData</a:t>
+· tools.init_worker_logging()
+· tools.redirect_uraster_logs()
+· landgen_io.write_mesh_to_geojson()
+· lc_rs.use_lc_rs()
+· lc_rs.read_to_geotiff()
+· landgen_io.regrid_to_mesh()</a:t>
             </a:r>
           </a:p>
         </p:txBody>
       </p:sp>
       <p:cxnSp>
         <p:nvCxnSpPr>
-          <p:cNvPr id="51" name="Arrow 51"/>
+          <p:cNvPr id="45" name="Arrow 45"/>
           <p:cNvCxnSpPr/>
           <p:nvPr/>
         </p:nvCxnSpPr>
         <p:spPr>
           <a:xfrm>
-            <a:off x="1170432" y="6583680"/>
-            <a:ext cx="1" cy="411480"/>
+            <a:off x="3191259" y="10012680"/>
+            <a:ext cx="3095241" cy="502920"/>
           </a:xfrm>
           <a:prstGeom prst="line">
             <a:avLst/>
@@ -5137,14 +4914,14 @@
       </p:cxnSp>
       <p:sp>
         <p:nvSpPr>
-          <p:cNvPr id="52" name="Rounded Rectangle 51"/>
+          <p:cNvPr id="46" name="Rounded Rectangle 45"/>
           <p:cNvSpPr/>
           <p:nvPr/>
         </p:nvSpPr>
         <p:spPr>
           <a:xfrm>
-            <a:off x="10222992" y="6995160"/>
-            <a:ext cx="1828800" cy="868680"/>
+            <a:off x="9304020" y="10515600"/>
+            <a:ext cx="5394960" cy="2487168"/>
           </a:xfrm>
           <a:prstGeom prst="roundRect">
             <a:avLst/>
@@ -5178,30 +4955,29 @@
           <a:p>
             <a:pPr algn="ctr"/>
             <a:r>
-              <a:rPr sz="950" b="0">
+              <a:rPr sz="1800" b="0">
                 <a:solidFill>
                   <a:srgbClr val="FFFFFF"/>
                 </a:solidFill>
               </a:rPr>
               <a:t>harvest_process()
-· read LUH2 harvest
-· read HYDE grazing
-· regrid (uraster)
-· write → LtData</a:t>
+· landgen_io.read_luh2_harvest()
+· landgen_io.read_hyde_grazing()
+· landgen_io.regrid_to_landgen_grid()</a:t>
             </a:r>
           </a:p>
         </p:txBody>
       </p:sp>
       <p:cxnSp>
         <p:nvCxnSpPr>
-          <p:cNvPr id="53" name="Arrow 53"/>
+          <p:cNvPr id="47" name="Arrow 47"/>
           <p:cNvCxnSpPr/>
           <p:nvPr/>
         </p:nvCxnSpPr>
         <p:spPr>
-          <a:xfrm>
-            <a:off x="11137392" y="6583680"/>
-            <a:ext cx="1" cy="411480"/>
+          <a:xfrm flipH="1">
+            <a:off x="12001500" y="10012680"/>
+            <a:ext cx="1110994" cy="502920"/>
           </a:xfrm>
           <a:prstGeom prst="line">
             <a:avLst/>
@@ -5214,292 +4990,34 @@
           </a:ln>
         </p:spPr>
       </p:cxnSp>
-      <p:sp>
-        <p:nvSpPr>
-          <p:cNvPr id="54" name="Rounded Rectangle 53"/>
-          <p:cNvSpPr/>
-          <p:nvPr/>
-        </p:nvSpPr>
-        <p:spPr>
-          <a:xfrm>
-            <a:off x="1234440" y="8275320"/>
-            <a:ext cx="3017520" cy="777240"/>
-          </a:xfrm>
-          <a:prstGeom prst="roundRect">
-            <a:avLst/>
-          </a:prstGeom>
-          <a:solidFill>
-            <a:srgbClr val="ED7D31"/>
-          </a:solidFill>
-          <a:ln w="9525">
-            <a:solidFill>
-              <a:srgbClr val="FFFFFF"/>
-            </a:solidFill>
-          </a:ln>
-        </p:spPr>
-        <p:style>
-          <a:lnRef idx="1">
-            <a:schemeClr val="accent1"/>
-          </a:lnRef>
-          <a:fillRef idx="3">
-            <a:schemeClr val="accent1"/>
-          </a:fillRef>
-          <a:effectRef idx="2">
-            <a:schemeClr val="accent1"/>
-          </a:effectRef>
-          <a:fontRef idx="minor">
-            <a:schemeClr val="lt1"/>
-          </a:fontRef>
-        </p:style>
-        <p:txBody>
-          <a:bodyPr rtlCol="0" anchor="ctr" wrap="square"/>
-          <a:lstStyle/>
-          <a:p>
-            <a:pPr algn="ctr"/>
-            <a:r>
-              <a:rPr sz="950" b="0">
-                <a:solidFill>
-                  <a:srgbClr val="FFFFFF"/>
-                </a:solidFill>
-              </a:rPr>
-              <a:t>read_luh2_harvest()
-LUH2 transitions.nc
-→ harvest arrays</a:t>
-            </a:r>
-          </a:p>
-        </p:txBody>
-      </p:sp>
-      <p:sp>
-        <p:nvSpPr>
-          <p:cNvPr id="55" name="Rounded Rectangle 54"/>
-          <p:cNvSpPr/>
-          <p:nvPr/>
-        </p:nvSpPr>
-        <p:spPr>
-          <a:xfrm>
-            <a:off x="4434840" y="8275320"/>
-            <a:ext cx="3017520" cy="777240"/>
-          </a:xfrm>
-          <a:prstGeom prst="roundRect">
-            <a:avLst/>
-          </a:prstGeom>
-          <a:solidFill>
-            <a:srgbClr val="ED7D31"/>
-          </a:solidFill>
-          <a:ln w="9525">
-            <a:solidFill>
-              <a:srgbClr val="FFFFFF"/>
-            </a:solidFill>
-          </a:ln>
-        </p:spPr>
-        <p:style>
-          <a:lnRef idx="1">
-            <a:schemeClr val="accent1"/>
-          </a:lnRef>
-          <a:fillRef idx="3">
-            <a:schemeClr val="accent1"/>
-          </a:fillRef>
-          <a:effectRef idx="2">
-            <a:schemeClr val="accent1"/>
-          </a:effectRef>
-          <a:fontRef idx="minor">
-            <a:schemeClr val="lt1"/>
-          </a:fontRef>
-        </p:style>
-        <p:txBody>
-          <a:bodyPr rtlCol="0" anchor="ctr" wrap="square"/>
-          <a:lstStyle/>
-          <a:p>
-            <a:pPr algn="ctr"/>
-            <a:r>
-              <a:rPr sz="950" b="0">
-                <a:solidFill>
-                  <a:srgbClr val="FFFFFF"/>
-                </a:solidFill>
-              </a:rPr>
-              <a:t>read_hyde_grazing()
-HYDE3.5 .nc files
-→ grazing arrays</a:t>
-            </a:r>
-          </a:p>
-        </p:txBody>
-      </p:sp>
-      <p:sp>
-        <p:nvSpPr>
-          <p:cNvPr id="56" name="Rounded Rectangle 55"/>
-          <p:cNvSpPr/>
-          <p:nvPr/>
-        </p:nvSpPr>
-        <p:spPr>
-          <a:xfrm>
-            <a:off x="7635240" y="8275320"/>
-            <a:ext cx="3017520" cy="777240"/>
-          </a:xfrm>
-          <a:prstGeom prst="roundRect">
-            <a:avLst/>
-          </a:prstGeom>
-          <a:solidFill>
-            <a:srgbClr val="ED7D31"/>
-          </a:solidFill>
-          <a:ln w="9525">
-            <a:solidFill>
-              <a:srgbClr val="FFFFFF"/>
-            </a:solidFill>
-          </a:ln>
-        </p:spPr>
-        <p:style>
-          <a:lnRef idx="1">
-            <a:schemeClr val="accent1"/>
-          </a:lnRef>
-          <a:fillRef idx="3">
-            <a:schemeClr val="accent1"/>
-          </a:fillRef>
-          <a:effectRef idx="2">
-            <a:schemeClr val="accent1"/>
-          </a:effectRef>
-          <a:fontRef idx="minor">
-            <a:schemeClr val="lt1"/>
-          </a:fontRef>
-        </p:style>
-        <p:txBody>
-          <a:bodyPr rtlCol="0" anchor="ctr" wrap="square"/>
-          <a:lstStyle/>
-          <a:p>
-            <a:pPr algn="ctr"/>
-            <a:r>
-              <a:rPr sz="950" b="0">
-                <a:solidFill>
-                  <a:srgbClr val="FFFFFF"/>
-                </a:solidFill>
-              </a:rPr>
-              <a:t>write_latlon_to_geotiff()
-2D lat-lon slice
-→ GeoTIFF</a:t>
-            </a:r>
-          </a:p>
-        </p:txBody>
-      </p:sp>
-      <p:sp>
-        <p:nvSpPr>
-          <p:cNvPr id="57" name="Rounded Rectangle 56"/>
-          <p:cNvSpPr/>
-          <p:nvPr/>
-        </p:nvSpPr>
-        <p:spPr>
-          <a:xfrm>
-            <a:off x="10835640" y="8275320"/>
-            <a:ext cx="3017520" cy="777240"/>
-          </a:xfrm>
-          <a:prstGeom prst="roundRect">
-            <a:avLst/>
-          </a:prstGeom>
-          <a:solidFill>
-            <a:srgbClr val="ED7D31"/>
-          </a:solidFill>
-          <a:ln w="9525">
-            <a:solidFill>
-              <a:srgbClr val="FFFFFF"/>
-            </a:solidFill>
-          </a:ln>
-        </p:spPr>
-        <p:style>
-          <a:lnRef idx="1">
-            <a:schemeClr val="accent1"/>
-          </a:lnRef>
-          <a:fillRef idx="3">
-            <a:schemeClr val="accent1"/>
-          </a:fillRef>
-          <a:effectRef idx="2">
-            <a:schemeClr val="accent1"/>
-          </a:effectRef>
-          <a:fontRef idx="minor">
-            <a:schemeClr val="lt1"/>
-          </a:fontRef>
-        </p:style>
-        <p:txBody>
-          <a:bodyPr rtlCol="0" anchor="ctr" wrap="square"/>
-          <a:lstStyle/>
-          <a:p>
-            <a:pPr algn="ctr"/>
-            <a:r>
-              <a:rPr sz="950" b="0">
-                <a:solidFill>
-                  <a:srgbClr val="FFFFFF"/>
-                </a:solidFill>
-              </a:rPr>
-              <a:t>write_chunk_mesh_
-to_geojson()
-HEALPix cells → GeoJSON</a:t>
-            </a:r>
-          </a:p>
-        </p:txBody>
-      </p:sp>
-      <p:sp>
-        <p:nvSpPr>
-          <p:cNvPr id="58" name="Rounded Rectangle 57"/>
-          <p:cNvSpPr/>
-          <p:nvPr/>
-        </p:nvSpPr>
-        <p:spPr>
-          <a:xfrm>
-            <a:off x="14036040" y="8275320"/>
-            <a:ext cx="3017520" cy="777240"/>
-          </a:xfrm>
-          <a:prstGeom prst="roundRect">
-            <a:avLst/>
-          </a:prstGeom>
-          <a:solidFill>
-            <a:srgbClr val="ED7D31"/>
-          </a:solidFill>
-          <a:ln w="9525">
-            <a:solidFill>
-              <a:srgbClr val="FFFFFF"/>
-            </a:solidFill>
-          </a:ln>
-        </p:spPr>
-        <p:style>
-          <a:lnRef idx="1">
-            <a:schemeClr val="accent1"/>
-          </a:lnRef>
-          <a:fillRef idx="3">
-            <a:schemeClr val="accent1"/>
-          </a:fillRef>
-          <a:effectRef idx="2">
-            <a:schemeClr val="accent1"/>
-          </a:effectRef>
-          <a:fontRef idx="minor">
-            <a:schemeClr val="lt1"/>
-          </a:fontRef>
-        </p:style>
-        <p:txBody>
-          <a:bodyPr rtlCol="0" anchor="ctr" wrap="square"/>
-          <a:lstStyle/>
-          <a:p>
-            <a:pPr algn="ctr"/>
-            <a:r>
-              <a:rPr sz="950" b="0">
-                <a:solidFill>
-                  <a:srgbClr val="FFFFFF"/>
-                </a:solidFill>
-              </a:rPr>
-              <a:t>regrid_to_landgen_
-grid()
-GeoTIFF + GeoJSON
-→ URaster → 1D array</a:t>
-            </a:r>
-          </a:p>
-        </p:txBody>
-      </p:sp>
-      <p:sp>
-        <p:nvSpPr>
-          <p:cNvPr id="59" name="TextBox 58"/>
+    </p:spTree>
+  </p:cSld>
+  <p:clrMapOvr>
+    <a:masterClrMapping/>
+  </p:clrMapOvr>
+</p:sld>
+</file>
+
+<file path=ppt/slides/slide2.xml><?xml version="1.0" encoding="utf-8"?>
+<p:sld xmlns:a="http://schemas.openxmlformats.org/drawingml/2006/main" xmlns:p="http://schemas.openxmlformats.org/presentationml/2006/main" xmlns:r="http://schemas.openxmlformats.org/officeDocument/2006/relationships">
+  <p:cSld>
+    <p:spTree>
+      <p:nvGrpSpPr>
+        <p:cNvPr id="1" name=""/>
+        <p:cNvGrpSpPr/>
+        <p:nvPr/>
+      </p:nvGrpSpPr>
+      <p:grpSpPr/>
+      <p:sp>
+        <p:nvSpPr>
+          <p:cNvPr id="2" name="TextBox 1"/>
           <p:cNvSpPr txBox="1"/>
           <p:nvPr/>
         </p:nvSpPr>
         <p:spPr>
           <a:xfrm>
-            <a:off x="1143000" y="8001000"/>
-            <a:ext cx="3657600" cy="228600"/>
+            <a:off x="182880" y="91440"/>
+            <a:ext cx="17922240" cy="457200"/>
           </a:xfrm>
           <a:prstGeom prst="rect">
             <a:avLst/>
@@ -5512,61 +5030,520 @@
           </a:bodyPr>
           <a:lstStyle/>
           <a:p>
-            <a:r>
-              <a:rPr sz="1100" b="1">
+            <a:pPr algn="ctr"/>
+            <a:r>
+              <a:rPr sz="2600" b="1">
                 <a:solidFill>
                   <a:srgbClr val="ED7D31"/>
                 </a:solidFill>
               </a:rPr>
-              <a:t>landgen_io.py  –  I/O utilities</a:t>
-            </a:r>
-          </a:p>
-        </p:txBody>
-      </p:sp>
-      <p:cxnSp>
-        <p:nvCxnSpPr>
-          <p:cNvPr id="60" name="Arrow 60"/>
-          <p:cNvCxnSpPr/>
+              <a:t>landgen_io.py – Function Summary</a:t>
+            </a:r>
+          </a:p>
+        </p:txBody>
+      </p:sp>
+      <p:sp>
+        <p:nvSpPr>
+          <p:cNvPr id="3" name="TextBox 2"/>
+          <p:cNvSpPr txBox="1"/>
           <p:nvPr/>
-        </p:nvCxnSpPr>
-        <p:spPr>
-          <a:xfrm>
-            <a:off x="1170432" y="7863840"/>
-            <a:ext cx="7607808" cy="411480"/>
-          </a:xfrm>
-          <a:prstGeom prst="line">
-            <a:avLst/>
-          </a:prstGeom>
-          <a:ln w="19050">
-            <a:solidFill>
-              <a:srgbClr val="404040"/>
-            </a:solidFill>
-            <a:tailEnd type="arrow" w="med" len="med"/>
-          </a:ln>
-        </p:spPr>
-      </p:cxnSp>
-      <p:cxnSp>
-        <p:nvCxnSpPr>
-          <p:cNvPr id="61" name="Arrow 61"/>
-          <p:cNvCxnSpPr/>
+        </p:nvSpPr>
+        <p:spPr>
+          <a:xfrm>
+            <a:off x="274320" y="594360"/>
+            <a:ext cx="17556480" cy="320040"/>
+          </a:xfrm>
+          <a:prstGeom prst="rect">
+            <a:avLst/>
+          </a:prstGeom>
+          <a:noFill/>
+        </p:spPr>
+        <p:txBody>
+          <a:bodyPr wrap="none">
+            <a:spAutoFit/>
+          </a:bodyPr>
+          <a:lstStyle/>
+          <a:p>
+            <a:r>
+              <a:rPr sz="1800">
+                <a:solidFill>
+                  <a:srgbClr val="000000"/>
+                </a:solidFill>
+              </a:rPr>
+              <a:t>Auto-parsed from src/landgen/landgen_io.py</a:t>
+            </a:r>
+          </a:p>
+        </p:txBody>
+      </p:sp>
+      <p:sp>
+        <p:nvSpPr>
+          <p:cNvPr id="4" name="TextBox 3"/>
+          <p:cNvSpPr txBox="1"/>
           <p:nvPr/>
-        </p:nvCxnSpPr>
-        <p:spPr>
-          <a:xfrm flipH="1">
-            <a:off x="8778240" y="7863840"/>
-            <a:ext cx="2359152" cy="411480"/>
-          </a:xfrm>
-          <a:prstGeom prst="line">
-            <a:avLst/>
-          </a:prstGeom>
-          <a:ln w="19050">
-            <a:solidFill>
-              <a:srgbClr val="404040"/>
-            </a:solidFill>
-            <a:tailEnd type="arrow" w="med" len="med"/>
-          </a:ln>
-        </p:spPr>
-      </p:cxnSp>
+        </p:nvSpPr>
+        <p:spPr>
+          <a:xfrm>
+            <a:off x="365760" y="1005840"/>
+            <a:ext cx="8595360" cy="11338560"/>
+          </a:xfrm>
+          <a:prstGeom prst="rect">
+            <a:avLst/>
+          </a:prstGeom>
+          <a:noFill/>
+        </p:spPr>
+        <p:txBody>
+          <a:bodyPr wrap="square">
+            <a:spAutoFit/>
+          </a:bodyPr>
+          <a:lstStyle/>
+          <a:p>
+            <a:pPr/>
+            <a:r>
+              <a:rPr sz="1800"/>
+              <a:t>set_decomp_cell_idx_ll_limits()  –  Populate chunk_indices and chunk_ll_limits in-place from the domain NetCDF.</a:t>
+            </a:r>
+          </a:p>
+          <a:p>
+            <a:pPr/>
+            <a:r>
+              <a:rPr sz="1800"/>
+              <a:t>load_mesh_nc()  –  Load HEALPix mesh data from a NetCDF domain file.</a:t>
+            </a:r>
+          </a:p>
+          <a:p>
+            <a:pPr/>
+            <a:r>
+              <a:rPr sz="1800"/>
+              <a:t>calc_ll_limits()  –  Calculate and return a list of tuples (min_lat, max_lat, min_lon, max_lon)</a:t>
+            </a:r>
+          </a:p>
+          <a:p>
+            <a:pPr/>
+            <a:r>
+              <a:rPr sz="1800"/>
+              <a:t>get_modis_tile_idxs_ll()  –  Get the MODIS tile indices for a lat/lon bounding box.</a:t>
+            </a:r>
+          </a:p>
+          <a:p>
+            <a:pPr/>
+            <a:r>
+              <a:rPr sz="1800"/>
+              <a:t>get_sds_string()  –  Scans HDF subdatasets and returns a pyModis SDS string.</a:t>
+            </a:r>
+          </a:p>
+          <a:p>
+            <a:pPr/>
+            <a:r>
+              <a:rPr sz="1800"/>
+              <a:t>read_modis_ll_to_geotiff()  –  Download MODIS HDF tiles for a given year, mosaic them, and convert each</a:t>
+            </a:r>
+          </a:p>
+          <a:p>
+            <a:pPr/>
+            <a:r>
+              <a:rPr sz="1800"/>
+              <a:t>read_netcdf_ll()  –  Read variables from a NetCDF file for a given year.</a:t>
+            </a:r>
+          </a:p>
+          <a:p>
+            <a:pPr/>
+            <a:r>
+              <a:rPr sz="1800"/>
+              <a:t>read_luh2_harvest()  –  Read LUH2 harvest variables for a given year.</a:t>
+            </a:r>
+          </a:p>
+        </p:txBody>
+      </p:sp>
+      <p:sp>
+        <p:nvSpPr>
+          <p:cNvPr id="5" name="TextBox 4"/>
+          <p:cNvSpPr txBox="1"/>
+          <p:nvPr/>
+        </p:nvSpPr>
+        <p:spPr>
+          <a:xfrm>
+            <a:off x="9326880" y="1005840"/>
+            <a:ext cx="8595360" cy="11338560"/>
+          </a:xfrm>
+          <a:prstGeom prst="rect">
+            <a:avLst/>
+          </a:prstGeom>
+          <a:noFill/>
+        </p:spPr>
+        <p:txBody>
+          <a:bodyPr wrap="square">
+            <a:spAutoFit/>
+          </a:bodyPr>
+          <a:lstStyle/>
+          <a:p>
+            <a:pPr/>
+            <a:r>
+              <a:rPr sz="1800"/>
+              <a:t>read_hyde_grazing()  –  Read HYDE3.5 grazing data for a given year.</a:t>
+            </a:r>
+          </a:p>
+          <a:p>
+            <a:pPr/>
+            <a:r>
+              <a:rPr sz="1800"/>
+              <a:t>write_latlon_to_geotiff()  –  Slice a 2D (lat, lon) source array to a lat-lon bounding box and write</a:t>
+            </a:r>
+          </a:p>
+          <a:p>
+            <a:pPr/>
+            <a:r>
+              <a:rPr sz="1800"/>
+              <a:t>write_mesh_to_geojson()  –  Write mesh cells from a GridData object to a GeoJSON file.</a:t>
+            </a:r>
+          </a:p>
+          <a:p>
+            <a:pPr/>
+            <a:r>
+              <a:rPr sz="1800"/>
+              <a:t>write_chunk_mesh_to_geojson()  –  Filter the global HEALPix mesh DataFrame to only the cells in cell_ids</a:t>
+            </a:r>
+          </a:p>
+          <a:p>
+            <a:pPr/>
+            <a:r>
+              <a:rPr sz="1800"/>
+              <a:t>regrid_to_landgen_grid()  –  Regrid a single 2D source variable onto the landgen HEALPix grid cells</a:t>
+            </a:r>
+          </a:p>
+          <a:p>
+            <a:pPr/>
+            <a:r>
+              <a:rPr sz="1800"/>
+              <a:t>regrid_to_mesh()  –  Regrid a single raster variable onto the landgen mesh cells for one chunk,</a:t>
+            </a:r>
+          </a:p>
+          <a:p>
+            <a:pPr/>
+            <a:r>
+              <a:rPr sz="1800"/>
+              <a:t>write_module_netcdf()  –  Write a NetCDF file containing grid geometry from out_grid_data plus</a:t>
+            </a:r>
+          </a:p>
+          <a:p>
+            <a:pPr/>
+            <a:r>
+              <a:rPr sz="1800"/>
+              <a:t>get_chunk_cell_ids()  –  Determine the landgen grid cell ids that intersect each lat-lon chunk.</a:t>
+            </a:r>
+          </a:p>
+        </p:txBody>
+      </p:sp>
+    </p:spTree>
+  </p:cSld>
+  <p:clrMapOvr>
+    <a:masterClrMapping/>
+  </p:clrMapOvr>
+</p:sld>
+</file>
+
+<file path=ppt/slides/slide3.xml><?xml version="1.0" encoding="utf-8"?>
+<p:sld xmlns:a="http://schemas.openxmlformats.org/drawingml/2006/main" xmlns:p="http://schemas.openxmlformats.org/presentationml/2006/main" xmlns:r="http://schemas.openxmlformats.org/officeDocument/2006/relationships">
+  <p:cSld>
+    <p:spTree>
+      <p:nvGrpSpPr>
+        <p:cNvPr id="1" name=""/>
+        <p:cNvGrpSpPr/>
+        <p:nvPr/>
+      </p:nvGrpSpPr>
+      <p:grpSpPr/>
+      <p:sp>
+        <p:nvSpPr>
+          <p:cNvPr id="2" name="TextBox 1"/>
+          <p:cNvSpPr txBox="1"/>
+          <p:nvPr/>
+        </p:nvSpPr>
+        <p:spPr>
+          <a:xfrm>
+            <a:off x="182880" y="91440"/>
+            <a:ext cx="17922240" cy="457200"/>
+          </a:xfrm>
+          <a:prstGeom prst="rect">
+            <a:avLst/>
+          </a:prstGeom>
+          <a:noFill/>
+        </p:spPr>
+        <p:txBody>
+          <a:bodyPr wrap="none">
+            <a:spAutoFit/>
+          </a:bodyPr>
+          <a:lstStyle/>
+          <a:p>
+            <a:pPr algn="ctr"/>
+            <a:r>
+              <a:rPr sz="2600" b="1">
+                <a:solidFill>
+                  <a:srgbClr val="2E75B6"/>
+                </a:solidFill>
+              </a:rPr>
+              <a:t>tools.py – Function Summary</a:t>
+            </a:r>
+          </a:p>
+        </p:txBody>
+      </p:sp>
+      <p:sp>
+        <p:nvSpPr>
+          <p:cNvPr id="3" name="TextBox 2"/>
+          <p:cNvSpPr txBox="1"/>
+          <p:nvPr/>
+        </p:nvSpPr>
+        <p:spPr>
+          <a:xfrm>
+            <a:off x="274320" y="594360"/>
+            <a:ext cx="17556480" cy="320040"/>
+          </a:xfrm>
+          <a:prstGeom prst="rect">
+            <a:avLst/>
+          </a:prstGeom>
+          <a:noFill/>
+        </p:spPr>
+        <p:txBody>
+          <a:bodyPr wrap="none">
+            <a:spAutoFit/>
+          </a:bodyPr>
+          <a:lstStyle/>
+          <a:p>
+            <a:r>
+              <a:rPr sz="1800">
+                <a:solidFill>
+                  <a:srgbClr val="000000"/>
+                </a:solidFill>
+              </a:rPr>
+              <a:t>Auto-parsed from src/landgen/tools.py</a:t>
+            </a:r>
+          </a:p>
+        </p:txBody>
+      </p:sp>
+      <p:sp>
+        <p:nvSpPr>
+          <p:cNvPr id="4" name="TextBox 3"/>
+          <p:cNvSpPr txBox="1"/>
+          <p:nvPr/>
+        </p:nvSpPr>
+        <p:spPr>
+          <a:xfrm>
+            <a:off x="365760" y="1005840"/>
+            <a:ext cx="8595360" cy="11338560"/>
+          </a:xfrm>
+          <a:prstGeom prst="rect">
+            <a:avLst/>
+          </a:prstGeom>
+          <a:noFill/>
+        </p:spPr>
+        <p:txBody>
+          <a:bodyPr wrap="square">
+            <a:spAutoFit/>
+          </a:bodyPr>
+          <a:lstStyle/>
+          <a:p>
+            <a:pPr/>
+            <a:r>
+              <a:rPr sz="1800"/>
+              <a:t>setup_logger()  –  Configure a named logger to write to log_path and to stdout.</a:t>
+            </a:r>
+          </a:p>
+          <a:p>
+            <a:pPr/>
+            <a:r>
+              <a:rPr sz="1800"/>
+              <a:t>init_worker_logging()  –  Attach a FileHandler (append mode) to the named logger inside a worker</a:t>
+            </a:r>
+          </a:p>
+          <a:p>
+            <a:pPr/>
+            <a:r>
+              <a:rPr sz="1800"/>
+              <a:t>redirect_uraster_logs()  –  Redirect uraster's auto-created log files from the process CWD to out_path.</a:t>
+            </a:r>
+          </a:p>
+        </p:txBody>
+      </p:sp>
+      <p:sp>
+        <p:nvSpPr>
+          <p:cNvPr id="5" name="TextBox 4"/>
+          <p:cNvSpPr txBox="1"/>
+          <p:nvPr/>
+        </p:nvSpPr>
+        <p:spPr>
+          <a:xfrm>
+            <a:off x="9326880" y="1005840"/>
+            <a:ext cx="8595360" cy="11338560"/>
+          </a:xfrm>
+          <a:prstGeom prst="rect">
+            <a:avLst/>
+          </a:prstGeom>
+          <a:noFill/>
+        </p:spPr>
+        <p:txBody>
+          <a:bodyPr wrap="square">
+            <a:spAutoFit/>
+          </a:bodyPr>
+          <a:lstStyle/>
+          <a:p>
+            <a:pPr/>
+            <a:r>
+              <a:rPr sz="1800"/>
+              <a:t>parse_cpu_env()  –  Return the integer value of an environment variable, or None if unset or</a:t>
+            </a:r>
+          </a:p>
+          <a:p>
+            <a:pPr/>
+            <a:r>
+              <a:rPr sz="1800"/>
+              <a:t>monitor_cluster_resources()  –  Periodically logs aggregated CPU and memory usage of the entire process tree.</a:t>
+            </a:r>
+          </a:p>
+        </p:txBody>
+      </p:sp>
+    </p:spTree>
+  </p:cSld>
+  <p:clrMapOvr>
+    <a:masterClrMapping/>
+  </p:clrMapOvr>
+</p:sld>
+</file>
+
+<file path=ppt/slides/slide4.xml><?xml version="1.0" encoding="utf-8"?>
+<p:sld xmlns:a="http://schemas.openxmlformats.org/drawingml/2006/main" xmlns:p="http://schemas.openxmlformats.org/presentationml/2006/main" xmlns:r="http://schemas.openxmlformats.org/officeDocument/2006/relationships">
+  <p:cSld>
+    <p:spTree>
+      <p:nvGrpSpPr>
+        <p:cNvPr id="1" name=""/>
+        <p:cNvGrpSpPr/>
+        <p:nvPr/>
+      </p:nvGrpSpPr>
+      <p:grpSpPr/>
+      <p:sp>
+        <p:nvSpPr>
+          <p:cNvPr id="2" name="TextBox 1"/>
+          <p:cNvSpPr txBox="1"/>
+          <p:nvPr/>
+        </p:nvSpPr>
+        <p:spPr>
+          <a:xfrm>
+            <a:off x="182880" y="91440"/>
+            <a:ext cx="17922240" cy="457200"/>
+          </a:xfrm>
+          <a:prstGeom prst="rect">
+            <a:avLst/>
+          </a:prstGeom>
+          <a:noFill/>
+        </p:spPr>
+        <p:txBody>
+          <a:bodyPr wrap="none">
+            <a:spAutoFit/>
+          </a:bodyPr>
+          <a:lstStyle/>
+          <a:p>
+            <a:pPr algn="ctr"/>
+            <a:r>
+              <a:rPr sz="2600" b="1">
+                <a:solidFill>
+                  <a:srgbClr val="1F497D"/>
+                </a:solidFill>
+              </a:rPr>
+              <a:t>plot_landgen.py – Function Summary</a:t>
+            </a:r>
+          </a:p>
+        </p:txBody>
+      </p:sp>
+      <p:sp>
+        <p:nvSpPr>
+          <p:cNvPr id="3" name="TextBox 2"/>
+          <p:cNvSpPr txBox="1"/>
+          <p:nvPr/>
+        </p:nvSpPr>
+        <p:spPr>
+          <a:xfrm>
+            <a:off x="274320" y="594360"/>
+            <a:ext cx="17556480" cy="320040"/>
+          </a:xfrm>
+          <a:prstGeom prst="rect">
+            <a:avLst/>
+          </a:prstGeom>
+          <a:noFill/>
+        </p:spPr>
+        <p:txBody>
+          <a:bodyPr wrap="none">
+            <a:spAutoFit/>
+          </a:bodyPr>
+          <a:lstStyle/>
+          <a:p>
+            <a:r>
+              <a:rPr sz="1800">
+                <a:solidFill>
+                  <a:srgbClr val="000000"/>
+                </a:solidFill>
+              </a:rPr>
+              <a:t>Auto-parsed from src/landgen/plot_landgen.py</a:t>
+            </a:r>
+          </a:p>
+        </p:txBody>
+      </p:sp>
+      <p:sp>
+        <p:nvSpPr>
+          <p:cNvPr id="4" name="TextBox 3"/>
+          <p:cNvSpPr txBox="1"/>
+          <p:nvPr/>
+        </p:nvSpPr>
+        <p:spPr>
+          <a:xfrm>
+            <a:off x="365760" y="1005840"/>
+            <a:ext cx="8595360" cy="11338560"/>
+          </a:xfrm>
+          <a:prstGeom prst="rect">
+            <a:avLst/>
+          </a:prstGeom>
+          <a:noFill/>
+        </p:spPr>
+        <p:txBody>
+          <a:bodyPr wrap="square">
+            <a:spAutoFit/>
+          </a:bodyPr>
+          <a:lstStyle/>
+          <a:p>
+            <a:pPr/>
+            <a:r>
+              <a:rPr sz="1800"/>
+              <a:t>plot_module_netcdf()  –  Plot one or more variables from a NetCDF file written by landgen.</a:t>
+            </a:r>
+          </a:p>
+        </p:txBody>
+      </p:sp>
+      <p:sp>
+        <p:nvSpPr>
+          <p:cNvPr id="5" name="TextBox 4"/>
+          <p:cNvSpPr txBox="1"/>
+          <p:nvPr/>
+        </p:nvSpPr>
+        <p:spPr>
+          <a:xfrm>
+            <a:off x="9326880" y="1005840"/>
+            <a:ext cx="8595360" cy="11338560"/>
+          </a:xfrm>
+          <a:prstGeom prst="rect">
+            <a:avLst/>
+          </a:prstGeom>
+          <a:noFill/>
+        </p:spPr>
+        <p:txBody>
+          <a:bodyPr wrap="square">
+            <a:spAutoFit/>
+          </a:bodyPr>
+          <a:lstStyle/>
+          <a:p>
+            <a:pPr/>
+            <a:r>
+              <a:rPr sz="1800"/>
+              <a:t>main()  –  CLI entry point for standalone plotting.</a:t>
+            </a:r>
+          </a:p>
+        </p:txBody>
+      </p:sp>
     </p:spTree>
   </p:cSld>
   <p:clrMapOvr>

</xml_diff>